<commit_message>
Session 6 rework: Build Something Real — build / test / iterate against 4 criteria
- 24 activities across D-A-K-D-C
- New LIA aim: leave with a working prototype to deploy with a real group in 4 weeks
- DISCOVER: Best Moment · Worst Moment · Quality Criteria Vote · Name a Good One · The Choose Test
- ACTIVITY: Define Your Group · Pick Your Tool · Build It (45 min strict) · One-Sentence Elevator · Self-Check · Readiness Stand-Up
- KEY IDEAS: Four criteria, three failures — Failure Mode Bingo · The 60-Second Rule · Whose Problem Are You Solving? · The Tool Dies Tomorrow Question
- DISCUSSION: Peer Test R1 · Iterate Fix One Thing · Peer Test R2 · Before vs After · The Critics' Circle
- CLOSING: Lightning Presentations · Programme Reflection · Final Takeaway · Deploy Date
- Opening Q: What does good digital youth work look like?
- Closing Q: If the tool changed tomorrow, what standards would still apply?
- Takeaway: deploy with real group within 4 weeks, write 1–2pp justification
</commit_message>
<xml_diff>
--- a/assets/downloads/Session-5-Where-Are-Young-People-Online.pptx
+++ b/assets/downloads/Session-5-Where-Are-Young-People-Online.pptx
@@ -5,40 +5,40 @@
     <p:sldMasterId id="2147483648" r:id="rId1"/>
   </p:sldMasterIdLst>
   <p:sldIdLst>
-    <p:sldId id="256" r:id="rId7"/>
-    <p:sldId id="257" r:id="rId8"/>
-    <p:sldId id="258" r:id="rId9"/>
-    <p:sldId id="259" r:id="rId10"/>
-    <p:sldId id="260" r:id="rId11"/>
-    <p:sldId id="261" r:id="rId12"/>
-    <p:sldId id="262" r:id="rId13"/>
-    <p:sldId id="263" r:id="rId14"/>
-    <p:sldId id="264" r:id="rId15"/>
-    <p:sldId id="265" r:id="rId16"/>
-    <p:sldId id="266" r:id="rId17"/>
-    <p:sldId id="267" r:id="rId18"/>
-    <p:sldId id="268" r:id="rId19"/>
-    <p:sldId id="269" r:id="rId20"/>
-    <p:sldId id="270" r:id="rId21"/>
-    <p:sldId id="271" r:id="rId22"/>
-    <p:sldId id="272" r:id="rId23"/>
-    <p:sldId id="273" r:id="rId24"/>
-    <p:sldId id="274" r:id="rId25"/>
-    <p:sldId id="275" r:id="rId26"/>
-    <p:sldId id="276" r:id="rId27"/>
-    <p:sldId id="277" r:id="rId28"/>
-    <p:sldId id="278" r:id="rId29"/>
-    <p:sldId id="279" r:id="rId30"/>
-    <p:sldId id="280" r:id="rId31"/>
-    <p:sldId id="281" r:id="rId32"/>
-    <p:sldId id="282" r:id="rId33"/>
-    <p:sldId id="283" r:id="rId34"/>
-    <p:sldId id="284" r:id="rId35"/>
-    <p:sldId id="285" r:id="rId36"/>
-    <p:sldId id="286" r:id="rId37"/>
-    <p:sldId id="287" r:id="rId38"/>
+    <p:sldId id="256" r:id="rId2"/>
+    <p:sldId id="257" r:id="rId3"/>
+    <p:sldId id="258" r:id="rId4"/>
+    <p:sldId id="259" r:id="rId5"/>
+    <p:sldId id="260" r:id="rId6"/>
+    <p:sldId id="261" r:id="rId7"/>
+    <p:sldId id="262" r:id="rId8"/>
+    <p:sldId id="263" r:id="rId9"/>
+    <p:sldId id="264" r:id="rId10"/>
+    <p:sldId id="265" r:id="rId11"/>
+    <p:sldId id="266" r:id="rId12"/>
+    <p:sldId id="267" r:id="rId13"/>
+    <p:sldId id="268" r:id="rId14"/>
+    <p:sldId id="269" r:id="rId15"/>
+    <p:sldId id="270" r:id="rId16"/>
+    <p:sldId id="271" r:id="rId17"/>
+    <p:sldId id="272" r:id="rId18"/>
+    <p:sldId id="273" r:id="rId19"/>
+    <p:sldId id="274" r:id="rId20"/>
+    <p:sldId id="275" r:id="rId21"/>
+    <p:sldId id="276" r:id="rId22"/>
+    <p:sldId id="277" r:id="rId23"/>
+    <p:sldId id="278" r:id="rId24"/>
+    <p:sldId id="279" r:id="rId25"/>
+    <p:sldId id="280" r:id="rId26"/>
+    <p:sldId id="281" r:id="rId27"/>
+    <p:sldId id="282" r:id="rId28"/>
+    <p:sldId id="283" r:id="rId29"/>
+    <p:sldId id="284" r:id="rId30"/>
+    <p:sldId id="285" r:id="rId31"/>
+    <p:sldId id="286" r:id="rId32"/>
+    <p:sldId id="287" r:id="rId33"/>
   </p:sldIdLst>
-  <p:sldSz cx="12191695" cy="6858000" type="screen4x3"/>
+  <p:sldSz cx="12192000" cy="6858000"/>
   <p:notesSz cx="6858000" cy="9144000"/>
   <p:defaultTextStyle>
     <a:defPPr>
@@ -135,6 +135,22 @@
       </a:defRPr>
     </a:lvl9pPr>
   </p:defaultTextStyle>
+  <p:extLst>
+    <p:ext uri="{EFAFB233-063F-42B5-8137-9DF3F51BA10A}">
+      <p15:sldGuideLst xmlns:p15="http://schemas.microsoft.com/office/powerpoint/2012/main">
+        <p15:guide id="1" orient="horz" pos="2160">
+          <p15:clr>
+            <a:srgbClr val="A4A3A4"/>
+          </p15:clr>
+        </p15:guide>
+        <p15:guide id="2" pos="2880">
+          <p15:clr>
+            <a:srgbClr val="A4A3A4"/>
+          </p15:clr>
+        </p15:guide>
+      </p15:sldGuideLst>
+    </p:ext>
+  </p:extLst>
 </p:presentation>
 </file>
 
@@ -176,10 +192,9 @@
           <a:lstStyle/>
           <a:p>
             <a:r>
-              <a:rPr lang="en-US" smtClean="0"/>
+              <a:rPr lang="en-US"/>
               <a:t>Click to edit Master title style</a:t>
             </a:r>
-            <a:endParaRPr lang="en-US"/>
           </a:p>
         </p:txBody>
       </p:sp>
@@ -295,10 +310,9 @@
           </a:lstStyle>
           <a:p>
             <a:r>
-              <a:rPr lang="en-US" smtClean="0"/>
+              <a:rPr lang="en-US"/>
               <a:t>Click to edit Master subtitle style</a:t>
             </a:r>
-            <a:endParaRPr lang="en-US"/>
           </a:p>
         </p:txBody>
       </p:sp>
@@ -319,7 +333,7 @@
           <a:p>
             <a:fld id="{5BCAD085-E8A6-8845-BD4E-CB4CCA059FC4}" type="datetimeFigureOut">
               <a:rPr lang="en-US" smtClean="0"/>
-              <a:t>1/27/13</a:t>
+              <a:t>4/16/26</a:t>
             </a:fld>
             <a:endParaRPr lang="en-US"/>
           </a:p>
@@ -413,10 +427,9 @@
           <a:lstStyle/>
           <a:p>
             <a:r>
-              <a:rPr lang="en-US" smtClean="0"/>
+              <a:rPr lang="en-US"/>
               <a:t>Click to edit Master title style</a:t>
             </a:r>
-            <a:endParaRPr lang="en-US"/>
           </a:p>
         </p:txBody>
       </p:sp>
@@ -437,38 +450,37 @@
           <a:p>
             <a:pPr lvl="0"/>
             <a:r>
-              <a:rPr lang="en-US" smtClean="0"/>
+              <a:rPr lang="en-US"/>
               <a:t>Click to edit Master text styles</a:t>
             </a:r>
           </a:p>
           <a:p>
             <a:pPr lvl="1"/>
             <a:r>
-              <a:rPr lang="en-US" smtClean="0"/>
+              <a:rPr lang="en-US"/>
               <a:t>Second level</a:t>
             </a:r>
           </a:p>
           <a:p>
             <a:pPr lvl="2"/>
             <a:r>
-              <a:rPr lang="en-US" smtClean="0"/>
+              <a:rPr lang="en-US"/>
               <a:t>Third level</a:t>
             </a:r>
           </a:p>
           <a:p>
             <a:pPr lvl="3"/>
             <a:r>
-              <a:rPr lang="en-US" smtClean="0"/>
+              <a:rPr lang="en-US"/>
               <a:t>Fourth level</a:t>
             </a:r>
           </a:p>
           <a:p>
             <a:pPr lvl="4"/>
             <a:r>
-              <a:rPr lang="en-US" smtClean="0"/>
+              <a:rPr lang="en-US"/>
               <a:t>Fifth level</a:t>
             </a:r>
-            <a:endParaRPr lang="en-US"/>
           </a:p>
         </p:txBody>
       </p:sp>
@@ -489,7 +501,7 @@
           <a:p>
             <a:fld id="{5BCAD085-E8A6-8845-BD4E-CB4CCA059FC4}" type="datetimeFigureOut">
               <a:rPr lang="en-US" smtClean="0"/>
-              <a:t>1/27/13</a:t>
+              <a:t>4/16/26</a:t>
             </a:fld>
             <a:endParaRPr lang="en-US"/>
           </a:p>
@@ -588,10 +600,9 @@
           <a:lstStyle/>
           <a:p>
             <a:r>
-              <a:rPr lang="en-US" smtClean="0"/>
+              <a:rPr lang="en-US"/>
               <a:t>Click to edit Master title style</a:t>
             </a:r>
-            <a:endParaRPr lang="en-US"/>
           </a:p>
         </p:txBody>
       </p:sp>
@@ -617,38 +628,37 @@
           <a:p>
             <a:pPr lvl="0"/>
             <a:r>
-              <a:rPr lang="en-US" smtClean="0"/>
+              <a:rPr lang="en-US"/>
               <a:t>Click to edit Master text styles</a:t>
             </a:r>
           </a:p>
           <a:p>
             <a:pPr lvl="1"/>
             <a:r>
-              <a:rPr lang="en-US" smtClean="0"/>
+              <a:rPr lang="en-US"/>
               <a:t>Second level</a:t>
             </a:r>
           </a:p>
           <a:p>
             <a:pPr lvl="2"/>
             <a:r>
-              <a:rPr lang="en-US" smtClean="0"/>
+              <a:rPr lang="en-US"/>
               <a:t>Third level</a:t>
             </a:r>
           </a:p>
           <a:p>
             <a:pPr lvl="3"/>
             <a:r>
-              <a:rPr lang="en-US" smtClean="0"/>
+              <a:rPr lang="en-US"/>
               <a:t>Fourth level</a:t>
             </a:r>
           </a:p>
           <a:p>
             <a:pPr lvl="4"/>
             <a:r>
-              <a:rPr lang="en-US" smtClean="0"/>
+              <a:rPr lang="en-US"/>
               <a:t>Fifth level</a:t>
             </a:r>
-            <a:endParaRPr lang="en-US"/>
           </a:p>
         </p:txBody>
       </p:sp>
@@ -669,7 +679,7 @@
           <a:p>
             <a:fld id="{5BCAD085-E8A6-8845-BD4E-CB4CCA059FC4}" type="datetimeFigureOut">
               <a:rPr lang="en-US" smtClean="0"/>
-              <a:t>1/27/13</a:t>
+              <a:t>4/16/26</a:t>
             </a:fld>
             <a:endParaRPr lang="en-US"/>
           </a:p>
@@ -763,10 +773,9 @@
           <a:lstStyle/>
           <a:p>
             <a:r>
-              <a:rPr lang="en-US" smtClean="0"/>
+              <a:rPr lang="en-US"/>
               <a:t>Click to edit Master title style</a:t>
             </a:r>
-            <a:endParaRPr lang="en-US"/>
           </a:p>
         </p:txBody>
       </p:sp>
@@ -787,38 +796,37 @@
           <a:p>
             <a:pPr lvl="0"/>
             <a:r>
-              <a:rPr lang="en-US" smtClean="0"/>
+              <a:rPr lang="en-US"/>
               <a:t>Click to edit Master text styles</a:t>
             </a:r>
           </a:p>
           <a:p>
             <a:pPr lvl="1"/>
             <a:r>
-              <a:rPr lang="en-US" smtClean="0"/>
+              <a:rPr lang="en-US"/>
               <a:t>Second level</a:t>
             </a:r>
           </a:p>
           <a:p>
             <a:pPr lvl="2"/>
             <a:r>
-              <a:rPr lang="en-US" smtClean="0"/>
+              <a:rPr lang="en-US"/>
               <a:t>Third level</a:t>
             </a:r>
           </a:p>
           <a:p>
             <a:pPr lvl="3"/>
             <a:r>
-              <a:rPr lang="en-US" smtClean="0"/>
+              <a:rPr lang="en-US"/>
               <a:t>Fourth level</a:t>
             </a:r>
           </a:p>
           <a:p>
             <a:pPr lvl="4"/>
             <a:r>
-              <a:rPr lang="en-US" smtClean="0"/>
+              <a:rPr lang="en-US"/>
               <a:t>Fifth level</a:t>
             </a:r>
-            <a:endParaRPr lang="en-US"/>
           </a:p>
         </p:txBody>
       </p:sp>
@@ -839,7 +847,7 @@
           <a:p>
             <a:fld id="{5BCAD085-E8A6-8845-BD4E-CB4CCA059FC4}" type="datetimeFigureOut">
               <a:rPr lang="en-US" smtClean="0"/>
-              <a:t>1/27/13</a:t>
+              <a:t>4/16/26</a:t>
             </a:fld>
             <a:endParaRPr lang="en-US"/>
           </a:p>
@@ -942,10 +950,9 @@
           </a:lstStyle>
           <a:p>
             <a:r>
-              <a:rPr lang="en-US" smtClean="0"/>
+              <a:rPr lang="en-US"/>
               <a:t>Click to edit Master title style</a:t>
             </a:r>
-            <a:endParaRPr lang="en-US"/>
           </a:p>
         </p:txBody>
       </p:sp>
@@ -1062,7 +1069,7 @@
           <a:p>
             <a:pPr lvl="0"/>
             <a:r>
-              <a:rPr lang="en-US" smtClean="0"/>
+              <a:rPr lang="en-US"/>
               <a:t>Click to edit Master text styles</a:t>
             </a:r>
           </a:p>
@@ -1085,7 +1092,7 @@
           <a:p>
             <a:fld id="{5BCAD085-E8A6-8845-BD4E-CB4CCA059FC4}" type="datetimeFigureOut">
               <a:rPr lang="en-US" smtClean="0"/>
-              <a:t>1/27/13</a:t>
+              <a:t>4/16/26</a:t>
             </a:fld>
             <a:endParaRPr lang="en-US"/>
           </a:p>
@@ -1179,10 +1186,9 @@
           <a:lstStyle/>
           <a:p>
             <a:r>
-              <a:rPr lang="en-US" smtClean="0"/>
+              <a:rPr lang="en-US"/>
               <a:t>Click to edit Master title style</a:t>
             </a:r>
-            <a:endParaRPr lang="en-US"/>
           </a:p>
         </p:txBody>
       </p:sp>
@@ -1236,38 +1242,37 @@
           <a:p>
             <a:pPr lvl="0"/>
             <a:r>
-              <a:rPr lang="en-US" smtClean="0"/>
+              <a:rPr lang="en-US"/>
               <a:t>Click to edit Master text styles</a:t>
             </a:r>
           </a:p>
           <a:p>
             <a:pPr lvl="1"/>
             <a:r>
-              <a:rPr lang="en-US" smtClean="0"/>
+              <a:rPr lang="en-US"/>
               <a:t>Second level</a:t>
             </a:r>
           </a:p>
           <a:p>
             <a:pPr lvl="2"/>
             <a:r>
-              <a:rPr lang="en-US" smtClean="0"/>
+              <a:rPr lang="en-US"/>
               <a:t>Third level</a:t>
             </a:r>
           </a:p>
           <a:p>
             <a:pPr lvl="3"/>
             <a:r>
-              <a:rPr lang="en-US" smtClean="0"/>
+              <a:rPr lang="en-US"/>
               <a:t>Fourth level</a:t>
             </a:r>
           </a:p>
           <a:p>
             <a:pPr lvl="4"/>
             <a:r>
-              <a:rPr lang="en-US" smtClean="0"/>
+              <a:rPr lang="en-US"/>
               <a:t>Fifth level</a:t>
             </a:r>
-            <a:endParaRPr lang="en-US"/>
           </a:p>
         </p:txBody>
       </p:sp>
@@ -1321,38 +1326,37 @@
           <a:p>
             <a:pPr lvl="0"/>
             <a:r>
-              <a:rPr lang="en-US" smtClean="0"/>
+              <a:rPr lang="en-US"/>
               <a:t>Click to edit Master text styles</a:t>
             </a:r>
           </a:p>
           <a:p>
             <a:pPr lvl="1"/>
             <a:r>
-              <a:rPr lang="en-US" smtClean="0"/>
+              <a:rPr lang="en-US"/>
               <a:t>Second level</a:t>
             </a:r>
           </a:p>
           <a:p>
             <a:pPr lvl="2"/>
             <a:r>
-              <a:rPr lang="en-US" smtClean="0"/>
+              <a:rPr lang="en-US"/>
               <a:t>Third level</a:t>
             </a:r>
           </a:p>
           <a:p>
             <a:pPr lvl="3"/>
             <a:r>
-              <a:rPr lang="en-US" smtClean="0"/>
+              <a:rPr lang="en-US"/>
               <a:t>Fourth level</a:t>
             </a:r>
           </a:p>
           <a:p>
             <a:pPr lvl="4"/>
             <a:r>
-              <a:rPr lang="en-US" smtClean="0"/>
+              <a:rPr lang="en-US"/>
               <a:t>Fifth level</a:t>
             </a:r>
-            <a:endParaRPr lang="en-US"/>
           </a:p>
         </p:txBody>
       </p:sp>
@@ -1373,7 +1377,7 @@
           <a:p>
             <a:fld id="{5BCAD085-E8A6-8845-BD4E-CB4CCA059FC4}" type="datetimeFigureOut">
               <a:rPr lang="en-US" smtClean="0"/>
-              <a:t>1/27/13</a:t>
+              <a:t>4/16/26</a:t>
             </a:fld>
             <a:endParaRPr lang="en-US"/>
           </a:p>
@@ -1471,10 +1475,9 @@
           </a:lstStyle>
           <a:p>
             <a:r>
-              <a:rPr lang="en-US" smtClean="0"/>
+              <a:rPr lang="en-US"/>
               <a:t>Click to edit Master title style</a:t>
             </a:r>
-            <a:endParaRPr lang="en-US"/>
           </a:p>
         </p:txBody>
       </p:sp>
@@ -1537,7 +1540,7 @@
           <a:p>
             <a:pPr lvl="0"/>
             <a:r>
-              <a:rPr lang="en-US" smtClean="0"/>
+              <a:rPr lang="en-US"/>
               <a:t>Click to edit Master text styles</a:t>
             </a:r>
           </a:p>
@@ -1593,38 +1596,37 @@
           <a:p>
             <a:pPr lvl="0"/>
             <a:r>
-              <a:rPr lang="en-US" smtClean="0"/>
+              <a:rPr lang="en-US"/>
               <a:t>Click to edit Master text styles</a:t>
             </a:r>
           </a:p>
           <a:p>
             <a:pPr lvl="1"/>
             <a:r>
-              <a:rPr lang="en-US" smtClean="0"/>
+              <a:rPr lang="en-US"/>
               <a:t>Second level</a:t>
             </a:r>
           </a:p>
           <a:p>
             <a:pPr lvl="2"/>
             <a:r>
-              <a:rPr lang="en-US" smtClean="0"/>
+              <a:rPr lang="en-US"/>
               <a:t>Third level</a:t>
             </a:r>
           </a:p>
           <a:p>
             <a:pPr lvl="3"/>
             <a:r>
-              <a:rPr lang="en-US" smtClean="0"/>
+              <a:rPr lang="en-US"/>
               <a:t>Fourth level</a:t>
             </a:r>
           </a:p>
           <a:p>
             <a:pPr lvl="4"/>
             <a:r>
-              <a:rPr lang="en-US" smtClean="0"/>
+              <a:rPr lang="en-US"/>
               <a:t>Fifth level</a:t>
             </a:r>
-            <a:endParaRPr lang="en-US"/>
           </a:p>
         </p:txBody>
       </p:sp>
@@ -1687,7 +1689,7 @@
           <a:p>
             <a:pPr lvl="0"/>
             <a:r>
-              <a:rPr lang="en-US" smtClean="0"/>
+              <a:rPr lang="en-US"/>
               <a:t>Click to edit Master text styles</a:t>
             </a:r>
           </a:p>
@@ -1743,38 +1745,37 @@
           <a:p>
             <a:pPr lvl="0"/>
             <a:r>
-              <a:rPr lang="en-US" smtClean="0"/>
+              <a:rPr lang="en-US"/>
               <a:t>Click to edit Master text styles</a:t>
             </a:r>
           </a:p>
           <a:p>
             <a:pPr lvl="1"/>
             <a:r>
-              <a:rPr lang="en-US" smtClean="0"/>
+              <a:rPr lang="en-US"/>
               <a:t>Second level</a:t>
             </a:r>
           </a:p>
           <a:p>
             <a:pPr lvl="2"/>
             <a:r>
-              <a:rPr lang="en-US" smtClean="0"/>
+              <a:rPr lang="en-US"/>
               <a:t>Third level</a:t>
             </a:r>
           </a:p>
           <a:p>
             <a:pPr lvl="3"/>
             <a:r>
-              <a:rPr lang="en-US" smtClean="0"/>
+              <a:rPr lang="en-US"/>
               <a:t>Fourth level</a:t>
             </a:r>
           </a:p>
           <a:p>
             <a:pPr lvl="4"/>
             <a:r>
-              <a:rPr lang="en-US" smtClean="0"/>
+              <a:rPr lang="en-US"/>
               <a:t>Fifth level</a:t>
             </a:r>
-            <a:endParaRPr lang="en-US"/>
           </a:p>
         </p:txBody>
       </p:sp>
@@ -1795,7 +1796,7 @@
           <a:p>
             <a:fld id="{5BCAD085-E8A6-8845-BD4E-CB4CCA059FC4}" type="datetimeFigureOut">
               <a:rPr lang="en-US" smtClean="0"/>
-              <a:t>1/27/13</a:t>
+              <a:t>4/16/26</a:t>
             </a:fld>
             <a:endParaRPr lang="en-US"/>
           </a:p>
@@ -1889,10 +1890,9 @@
           <a:lstStyle/>
           <a:p>
             <a:r>
-              <a:rPr lang="en-US" smtClean="0"/>
+              <a:rPr lang="en-US"/>
               <a:t>Click to edit Master title style</a:t>
             </a:r>
-            <a:endParaRPr lang="en-US"/>
           </a:p>
         </p:txBody>
       </p:sp>
@@ -1913,7 +1913,7 @@
           <a:p>
             <a:fld id="{5BCAD085-E8A6-8845-BD4E-CB4CCA059FC4}" type="datetimeFigureOut">
               <a:rPr lang="en-US" smtClean="0"/>
-              <a:t>1/27/13</a:t>
+              <a:t>4/16/26</a:t>
             </a:fld>
             <a:endParaRPr lang="en-US"/>
           </a:p>
@@ -2008,7 +2008,7 @@
           <a:p>
             <a:fld id="{5BCAD085-E8A6-8845-BD4E-CB4CCA059FC4}" type="datetimeFigureOut">
               <a:rPr lang="en-US" smtClean="0"/>
-              <a:t>1/27/13</a:t>
+              <a:t>4/16/26</a:t>
             </a:fld>
             <a:endParaRPr lang="en-US"/>
           </a:p>
@@ -2111,10 +2111,9 @@
           </a:lstStyle>
           <a:p>
             <a:r>
-              <a:rPr lang="en-US" smtClean="0"/>
+              <a:rPr lang="en-US"/>
               <a:t>Click to edit Master title style</a:t>
             </a:r>
-            <a:endParaRPr lang="en-US"/>
           </a:p>
         </p:txBody>
       </p:sp>
@@ -2168,38 +2167,37 @@
           <a:p>
             <a:pPr lvl="0"/>
             <a:r>
-              <a:rPr lang="en-US" smtClean="0"/>
+              <a:rPr lang="en-US"/>
               <a:t>Click to edit Master text styles</a:t>
             </a:r>
           </a:p>
           <a:p>
             <a:pPr lvl="1"/>
             <a:r>
-              <a:rPr lang="en-US" smtClean="0"/>
+              <a:rPr lang="en-US"/>
               <a:t>Second level</a:t>
             </a:r>
           </a:p>
           <a:p>
             <a:pPr lvl="2"/>
             <a:r>
-              <a:rPr lang="en-US" smtClean="0"/>
+              <a:rPr lang="en-US"/>
               <a:t>Third level</a:t>
             </a:r>
           </a:p>
           <a:p>
             <a:pPr lvl="3"/>
             <a:r>
-              <a:rPr lang="en-US" smtClean="0"/>
+              <a:rPr lang="en-US"/>
               <a:t>Fourth level</a:t>
             </a:r>
           </a:p>
           <a:p>
             <a:pPr lvl="4"/>
             <a:r>
-              <a:rPr lang="en-US" smtClean="0"/>
+              <a:rPr lang="en-US"/>
               <a:t>Fifth level</a:t>
             </a:r>
-            <a:endParaRPr lang="en-US"/>
           </a:p>
         </p:txBody>
       </p:sp>
@@ -2262,7 +2260,7 @@
           <a:p>
             <a:pPr lvl="0"/>
             <a:r>
-              <a:rPr lang="en-US" smtClean="0"/>
+              <a:rPr lang="en-US"/>
               <a:t>Click to edit Master text styles</a:t>
             </a:r>
           </a:p>
@@ -2285,7 +2283,7 @@
           <a:p>
             <a:fld id="{5BCAD085-E8A6-8845-BD4E-CB4CCA059FC4}" type="datetimeFigureOut">
               <a:rPr lang="en-US" smtClean="0"/>
-              <a:t>1/27/13</a:t>
+              <a:t>4/16/26</a:t>
             </a:fld>
             <a:endParaRPr lang="en-US"/>
           </a:p>
@@ -2388,10 +2386,9 @@
           </a:lstStyle>
           <a:p>
             <a:r>
-              <a:rPr lang="en-US" smtClean="0"/>
+              <a:rPr lang="en-US"/>
               <a:t>Click to edit Master title style</a:t>
             </a:r>
-            <a:endParaRPr lang="en-US"/>
           </a:p>
         </p:txBody>
       </p:sp>
@@ -2515,7 +2512,7 @@
           <a:p>
             <a:pPr lvl="0"/>
             <a:r>
-              <a:rPr lang="en-US" smtClean="0"/>
+              <a:rPr lang="en-US"/>
               <a:t>Click to edit Master text styles</a:t>
             </a:r>
           </a:p>
@@ -2538,7 +2535,7 @@
           <a:p>
             <a:fld id="{5BCAD085-E8A6-8845-BD4E-CB4CCA059FC4}" type="datetimeFigureOut">
               <a:rPr lang="en-US" smtClean="0"/>
-              <a:t>1/27/13</a:t>
+              <a:t>4/16/26</a:t>
             </a:fld>
             <a:endParaRPr lang="en-US"/>
           </a:p>
@@ -2647,10 +2644,9 @@
           <a:lstStyle/>
           <a:p>
             <a:r>
-              <a:rPr lang="en-US" smtClean="0"/>
+              <a:rPr lang="en-US"/>
               <a:t>Click to edit Master title style</a:t>
             </a:r>
-            <a:endParaRPr lang="en-US"/>
           </a:p>
         </p:txBody>
       </p:sp>
@@ -2681,38 +2677,37 @@
           <a:p>
             <a:pPr lvl="0"/>
             <a:r>
-              <a:rPr lang="en-US" smtClean="0"/>
+              <a:rPr lang="en-US"/>
               <a:t>Click to edit Master text styles</a:t>
             </a:r>
           </a:p>
           <a:p>
             <a:pPr lvl="1"/>
             <a:r>
-              <a:rPr lang="en-US" smtClean="0"/>
+              <a:rPr lang="en-US"/>
               <a:t>Second level</a:t>
             </a:r>
           </a:p>
           <a:p>
             <a:pPr lvl="2"/>
             <a:r>
-              <a:rPr lang="en-US" smtClean="0"/>
+              <a:rPr lang="en-US"/>
               <a:t>Third level</a:t>
             </a:r>
           </a:p>
           <a:p>
             <a:pPr lvl="3"/>
             <a:r>
-              <a:rPr lang="en-US" smtClean="0"/>
+              <a:rPr lang="en-US"/>
               <a:t>Fourth level</a:t>
             </a:r>
           </a:p>
           <a:p>
             <a:pPr lvl="4"/>
             <a:r>
-              <a:rPr lang="en-US" smtClean="0"/>
+              <a:rPr lang="en-US"/>
               <a:t>Fifth level</a:t>
             </a:r>
-            <a:endParaRPr lang="en-US"/>
           </a:p>
         </p:txBody>
       </p:sp>
@@ -2751,7 +2746,7 @@
           <a:p>
             <a:fld id="{5BCAD085-E8A6-8845-BD4E-CB4CCA059FC4}" type="datetimeFigureOut">
               <a:rPr lang="en-US" smtClean="0"/>
-              <a:t>1/27/13</a:t>
+              <a:t>4/16/26</a:t>
             </a:fld>
             <a:endParaRPr lang="en-US"/>
           </a:p>
@@ -3110,7 +3105,7 @@
 </file>
 
 <file path=ppt/slides/slide1.xml><?xml version="1.0" encoding="utf-8"?>
-<p:sld xmlns:a="http://schemas.openxmlformats.org/drawingml/2006/main" xmlns:p="http://schemas.openxmlformats.org/presentationml/2006/main" xmlns:r="http://schemas.openxmlformats.org/officeDocument/2006/relationships">
+<p:sld xmlns:a="http://schemas.openxmlformats.org/drawingml/2006/main" xmlns:r="http://schemas.openxmlformats.org/officeDocument/2006/relationships" xmlns:p="http://schemas.openxmlformats.org/presentationml/2006/main">
   <p:cSld>
     <p:bg>
       <p:bgPr>
@@ -3126,7 +3121,14 @@
         <p:cNvGrpSpPr/>
         <p:nvPr/>
       </p:nvGrpSpPr>
-      <p:grpSpPr/>
+      <p:grpSpPr>
+        <a:xfrm>
+          <a:off x="0" y="0"/>
+          <a:ext cx="0" cy="0"/>
+          <a:chOff x="0" y="0"/>
+          <a:chExt cx="0" cy="0"/>
+        </a:xfrm>
+      </p:grpSpPr>
       <p:sp>
         <p:nvSpPr>
           <p:cNvPr id="2" name="Rectangle 1"/>
@@ -3167,6 +3169,7 @@
           <a:lstStyle/>
           <a:p>
             <a:pPr algn="ctr"/>
+            <a:endParaRPr/>
           </a:p>
         </p:txBody>
       </p:sp>
@@ -3210,6 +3213,7 @@
           <a:lstStyle/>
           <a:p>
             <a:pPr algn="ctr"/>
+            <a:endParaRPr/>
           </a:p>
         </p:txBody>
       </p:sp>
@@ -3253,6 +3257,7 @@
           <a:lstStyle/>
           <a:p>
             <a:pPr algn="ctr"/>
+            <a:endParaRPr/>
           </a:p>
         </p:txBody>
       </p:sp>
@@ -3296,6 +3301,7 @@
           <a:lstStyle/>
           <a:p>
             <a:pPr algn="ctr"/>
+            <a:endParaRPr/>
           </a:p>
         </p:txBody>
       </p:sp>
@@ -3339,6 +3345,7 @@
           <a:lstStyle/>
           <a:p>
             <a:pPr algn="ctr"/>
+            <a:endParaRPr/>
           </a:p>
         </p:txBody>
       </p:sp>
@@ -3382,6 +3389,7 @@
           <a:lstStyle/>
           <a:p>
             <a:pPr algn="ctr"/>
+            <a:endParaRPr/>
           </a:p>
         </p:txBody>
       </p:sp>
@@ -3586,7 +3594,7 @@
 </file>
 
 <file path=ppt/slides/slide10.xml><?xml version="1.0" encoding="utf-8"?>
-<p:sld xmlns:a="http://schemas.openxmlformats.org/drawingml/2006/main" xmlns:p="http://schemas.openxmlformats.org/presentationml/2006/main" xmlns:r="http://schemas.openxmlformats.org/officeDocument/2006/relationships">
+<p:sld xmlns:a="http://schemas.openxmlformats.org/drawingml/2006/main" xmlns:r="http://schemas.openxmlformats.org/officeDocument/2006/relationships" xmlns:p="http://schemas.openxmlformats.org/presentationml/2006/main">
   <p:cSld>
     <p:bg>
       <p:bgPr>
@@ -3602,7 +3610,14 @@
         <p:cNvGrpSpPr/>
         <p:nvPr/>
       </p:nvGrpSpPr>
-      <p:grpSpPr/>
+      <p:grpSpPr>
+        <a:xfrm>
+          <a:off x="0" y="0"/>
+          <a:ext cx="0" cy="0"/>
+          <a:chOff x="0" y="0"/>
+          <a:chExt cx="0" cy="0"/>
+        </a:xfrm>
+      </p:grpSpPr>
       <p:sp>
         <p:nvSpPr>
           <p:cNvPr id="2" name="Rectangle 1"/>
@@ -3643,6 +3658,7 @@
           <a:lstStyle/>
           <a:p>
             <a:pPr algn="ctr"/>
+            <a:endParaRPr/>
           </a:p>
         </p:txBody>
       </p:sp>
@@ -3726,7 +3742,7 @@
         </p:nvSpPr>
         <p:spPr>
           <a:xfrm>
-            <a:off x="731520" y="2103120"/>
+            <a:off x="731520" y="1623060"/>
             <a:ext cx="10515600" cy="2011680"/>
           </a:xfrm>
           <a:prstGeom prst="rect">
@@ -3749,6 +3765,7 @@
               </a:defRPr>
             </a:pPr>
             <a:r>
+              <a:rPr dirty="0"/>
               <a:t>In groups of 2–3, pick a platform your young people actually use. Audit it LIVE on your phones (not from memory) against the 5 criteria on screen. Rate each 1–5. Write specific evidence — screenshots, number of taps, names of settings. Opinions don't count here.</a:t>
             </a:r>
           </a:p>
@@ -3762,7 +3779,7 @@
         </p:nvSpPr>
         <p:spPr>
           <a:xfrm>
-            <a:off x="731520" y="4206240"/>
+            <a:off x="731520" y="2788920"/>
             <a:ext cx="10515600" cy="320040"/>
           </a:xfrm>
           <a:prstGeom prst="rect">
@@ -3785,6 +3802,7 @@
               </a:defRPr>
             </a:pPr>
             <a:r>
+              <a:rPr dirty="0"/>
               <a:t>PROMPTS</a:t>
             </a:r>
           </a:p>
@@ -3798,7 +3816,7 @@
         </p:nvSpPr>
         <p:spPr>
           <a:xfrm>
-            <a:off x="731520" y="4526280"/>
+            <a:off x="731520" y="3108960"/>
             <a:ext cx="10515600" cy="2103120"/>
           </a:xfrm>
           <a:prstGeom prst="rect">
@@ -3962,7 +3980,7 @@
 </file>
 
 <file path=ppt/slides/slide11.xml><?xml version="1.0" encoding="utf-8"?>
-<p:sld xmlns:a="http://schemas.openxmlformats.org/drawingml/2006/main" xmlns:p="http://schemas.openxmlformats.org/presentationml/2006/main" xmlns:r="http://schemas.openxmlformats.org/officeDocument/2006/relationships">
+<p:sld xmlns:a="http://schemas.openxmlformats.org/drawingml/2006/main" xmlns:r="http://schemas.openxmlformats.org/officeDocument/2006/relationships" xmlns:p="http://schemas.openxmlformats.org/presentationml/2006/main">
   <p:cSld>
     <p:bg>
       <p:bgPr>
@@ -3978,7 +3996,14 @@
         <p:cNvGrpSpPr/>
         <p:nvPr/>
       </p:nvGrpSpPr>
-      <p:grpSpPr/>
+      <p:grpSpPr>
+        <a:xfrm>
+          <a:off x="0" y="0"/>
+          <a:ext cx="0" cy="0"/>
+          <a:chOff x="0" y="0"/>
+          <a:chExt cx="0" cy="0"/>
+        </a:xfrm>
+      </p:grpSpPr>
       <p:sp>
         <p:nvSpPr>
           <p:cNvPr id="2" name="Rectangle 1"/>
@@ -4019,6 +4044,7 @@
           <a:lstStyle/>
           <a:p>
             <a:pPr algn="ctr"/>
+            <a:endParaRPr/>
           </a:p>
         </p:txBody>
       </p:sp>
@@ -4199,7 +4225,7 @@
 </file>
 
 <file path=ppt/slides/slide12.xml><?xml version="1.0" encoding="utf-8"?>
-<p:sld xmlns:a="http://schemas.openxmlformats.org/drawingml/2006/main" xmlns:p="http://schemas.openxmlformats.org/presentationml/2006/main" xmlns:r="http://schemas.openxmlformats.org/officeDocument/2006/relationships">
+<p:sld xmlns:a="http://schemas.openxmlformats.org/drawingml/2006/main" xmlns:r="http://schemas.openxmlformats.org/officeDocument/2006/relationships" xmlns:p="http://schemas.openxmlformats.org/presentationml/2006/main">
   <p:cSld>
     <p:bg>
       <p:bgPr>
@@ -4215,7 +4241,14 @@
         <p:cNvGrpSpPr/>
         <p:nvPr/>
       </p:nvGrpSpPr>
-      <p:grpSpPr/>
+      <p:grpSpPr>
+        <a:xfrm>
+          <a:off x="0" y="0"/>
+          <a:ext cx="0" cy="0"/>
+          <a:chOff x="0" y="0"/>
+          <a:chExt cx="0" cy="0"/>
+        </a:xfrm>
+      </p:grpSpPr>
       <p:sp>
         <p:nvSpPr>
           <p:cNvPr id="2" name="Rectangle 1"/>
@@ -4256,6 +4289,7 @@
           <a:lstStyle/>
           <a:p>
             <a:pPr algn="ctr"/>
+            <a:endParaRPr/>
           </a:p>
         </p:txBody>
       </p:sp>
@@ -4436,7 +4470,7 @@
 </file>
 
 <file path=ppt/slides/slide13.xml><?xml version="1.0" encoding="utf-8"?>
-<p:sld xmlns:a="http://schemas.openxmlformats.org/drawingml/2006/main" xmlns:p="http://schemas.openxmlformats.org/presentationml/2006/main" xmlns:r="http://schemas.openxmlformats.org/officeDocument/2006/relationships">
+<p:sld xmlns:a="http://schemas.openxmlformats.org/drawingml/2006/main" xmlns:r="http://schemas.openxmlformats.org/officeDocument/2006/relationships" xmlns:p="http://schemas.openxmlformats.org/presentationml/2006/main">
   <p:cSld>
     <p:bg>
       <p:bgPr>
@@ -4452,7 +4486,14 @@
         <p:cNvGrpSpPr/>
         <p:nvPr/>
       </p:nvGrpSpPr>
-      <p:grpSpPr/>
+      <p:grpSpPr>
+        <a:xfrm>
+          <a:off x="0" y="0"/>
+          <a:ext cx="0" cy="0"/>
+          <a:chOff x="0" y="0"/>
+          <a:chExt cx="0" cy="0"/>
+        </a:xfrm>
+      </p:grpSpPr>
       <p:sp>
         <p:nvSpPr>
           <p:cNvPr id="2" name="Rectangle 1"/>
@@ -4493,6 +4534,7 @@
           <a:lstStyle/>
           <a:p>
             <a:pPr algn="ctr"/>
+            <a:endParaRPr/>
           </a:p>
         </p:txBody>
       </p:sp>
@@ -4673,7 +4715,7 @@
 </file>
 
 <file path=ppt/slides/slide14.xml><?xml version="1.0" encoding="utf-8"?>
-<p:sld xmlns:a="http://schemas.openxmlformats.org/drawingml/2006/main" xmlns:p="http://schemas.openxmlformats.org/presentationml/2006/main" xmlns:r="http://schemas.openxmlformats.org/officeDocument/2006/relationships">
+<p:sld xmlns:a="http://schemas.openxmlformats.org/drawingml/2006/main" xmlns:r="http://schemas.openxmlformats.org/officeDocument/2006/relationships" xmlns:p="http://schemas.openxmlformats.org/presentationml/2006/main">
   <p:cSld>
     <p:bg>
       <p:bgPr>
@@ -4689,7 +4731,14 @@
         <p:cNvGrpSpPr/>
         <p:nvPr/>
       </p:nvGrpSpPr>
-      <p:grpSpPr/>
+      <p:grpSpPr>
+        <a:xfrm>
+          <a:off x="0" y="0"/>
+          <a:ext cx="0" cy="0"/>
+          <a:chOff x="0" y="0"/>
+          <a:chExt cx="0" cy="0"/>
+        </a:xfrm>
+      </p:grpSpPr>
       <p:sp>
         <p:nvSpPr>
           <p:cNvPr id="2" name="Rectangle 1"/>
@@ -4730,6 +4779,7 @@
           <a:lstStyle/>
           <a:p>
             <a:pPr algn="ctr"/>
+            <a:endParaRPr/>
           </a:p>
         </p:txBody>
       </p:sp>
@@ -4910,7 +4960,7 @@
 </file>
 
 <file path=ppt/slides/slide15.xml><?xml version="1.0" encoding="utf-8"?>
-<p:sld xmlns:a="http://schemas.openxmlformats.org/drawingml/2006/main" xmlns:p="http://schemas.openxmlformats.org/presentationml/2006/main" xmlns:r="http://schemas.openxmlformats.org/officeDocument/2006/relationships">
+<p:sld xmlns:a="http://schemas.openxmlformats.org/drawingml/2006/main" xmlns:r="http://schemas.openxmlformats.org/officeDocument/2006/relationships" xmlns:p="http://schemas.openxmlformats.org/presentationml/2006/main">
   <p:cSld>
     <p:bg>
       <p:bgPr>
@@ -4926,7 +4976,14 @@
         <p:cNvGrpSpPr/>
         <p:nvPr/>
       </p:nvGrpSpPr>
-      <p:grpSpPr/>
+      <p:grpSpPr>
+        <a:xfrm>
+          <a:off x="0" y="0"/>
+          <a:ext cx="0" cy="0"/>
+          <a:chOff x="0" y="0"/>
+          <a:chExt cx="0" cy="0"/>
+        </a:xfrm>
+      </p:grpSpPr>
       <p:sp>
         <p:nvSpPr>
           <p:cNvPr id="2" name="Rectangle 1"/>
@@ -4967,6 +5024,7 @@
           <a:lstStyle/>
           <a:p>
             <a:pPr algn="ctr"/>
+            <a:endParaRPr/>
           </a:p>
         </p:txBody>
       </p:sp>
@@ -5147,7 +5205,7 @@
 </file>
 
 <file path=ppt/slides/slide16.xml><?xml version="1.0" encoding="utf-8"?>
-<p:sld xmlns:a="http://schemas.openxmlformats.org/drawingml/2006/main" xmlns:p="http://schemas.openxmlformats.org/presentationml/2006/main" xmlns:r="http://schemas.openxmlformats.org/officeDocument/2006/relationships">
+<p:sld xmlns:a="http://schemas.openxmlformats.org/drawingml/2006/main" xmlns:r="http://schemas.openxmlformats.org/officeDocument/2006/relationships" xmlns:p="http://schemas.openxmlformats.org/presentationml/2006/main">
   <p:cSld>
     <p:bg>
       <p:bgPr>
@@ -5163,7 +5221,14 @@
         <p:cNvGrpSpPr/>
         <p:nvPr/>
       </p:nvGrpSpPr>
-      <p:grpSpPr/>
+      <p:grpSpPr>
+        <a:xfrm>
+          <a:off x="0" y="0"/>
+          <a:ext cx="0" cy="0"/>
+          <a:chOff x="0" y="0"/>
+          <a:chExt cx="0" cy="0"/>
+        </a:xfrm>
+      </p:grpSpPr>
       <p:sp>
         <p:nvSpPr>
           <p:cNvPr id="2" name="Rectangle 1"/>
@@ -5204,6 +5269,7 @@
           <a:lstStyle/>
           <a:p>
             <a:pPr algn="ctr"/>
+            <a:endParaRPr/>
           </a:p>
         </p:txBody>
       </p:sp>
@@ -5463,7 +5529,7 @@
 </file>
 
 <file path=ppt/slides/slide17.xml><?xml version="1.0" encoding="utf-8"?>
-<p:sld xmlns:a="http://schemas.openxmlformats.org/drawingml/2006/main" xmlns:p="http://schemas.openxmlformats.org/presentationml/2006/main" xmlns:r="http://schemas.openxmlformats.org/officeDocument/2006/relationships">
+<p:sld xmlns:a="http://schemas.openxmlformats.org/drawingml/2006/main" xmlns:r="http://schemas.openxmlformats.org/officeDocument/2006/relationships" xmlns:p="http://schemas.openxmlformats.org/presentationml/2006/main">
   <p:cSld>
     <p:bg>
       <p:bgPr>
@@ -5479,7 +5545,14 @@
         <p:cNvGrpSpPr/>
         <p:nvPr/>
       </p:nvGrpSpPr>
-      <p:grpSpPr/>
+      <p:grpSpPr>
+        <a:xfrm>
+          <a:off x="0" y="0"/>
+          <a:ext cx="0" cy="0"/>
+          <a:chOff x="0" y="0"/>
+          <a:chExt cx="0" cy="0"/>
+        </a:xfrm>
+      </p:grpSpPr>
       <p:sp>
         <p:nvSpPr>
           <p:cNvPr id="2" name="Rectangle 1"/>
@@ -5520,6 +5593,7 @@
           <a:lstStyle/>
           <a:p>
             <a:pPr algn="ctr"/>
+            <a:endParaRPr/>
           </a:p>
         </p:txBody>
       </p:sp>
@@ -5603,43 +5677,43 @@
         </p:nvSpPr>
         <p:spPr>
           <a:xfrm>
+            <a:off x="731520" y="1645920"/>
+            <a:ext cx="10515600" cy="365760"/>
+          </a:xfrm>
+          <a:prstGeom prst="rect">
+            <a:avLst/>
+          </a:prstGeom>
+          <a:noFill/>
+        </p:spPr>
+        <p:txBody>
+          <a:bodyPr wrap="square" lIns="0" rIns="0">
+            <a:spAutoFit/>
+          </a:bodyPr>
+          <a:lstStyle/>
+          <a:p>
+            <a:pPr algn="l">
+              <a:defRPr sz="1400" b="1">
+                <a:solidFill>
+                  <a:srgbClr val="E91E8C"/>
+                </a:solidFill>
+                <a:latin typeface="Calibri"/>
+              </a:defRPr>
+            </a:pPr>
+            <a:r>
+              <a:t>🛠  Mentimeter</a:t>
+            </a:r>
+          </a:p>
+        </p:txBody>
+      </p:sp>
+      <p:sp>
+        <p:nvSpPr>
+          <p:cNvPr id="6" name="TextBox 5"/>
+          <p:cNvSpPr txBox="1"/>
+          <p:nvPr/>
+        </p:nvSpPr>
+        <p:spPr>
+          <a:xfrm>
             <a:off x="731520" y="2103120"/>
-            <a:ext cx="10515600" cy="365760"/>
-          </a:xfrm>
-          <a:prstGeom prst="rect">
-            <a:avLst/>
-          </a:prstGeom>
-          <a:noFill/>
-        </p:spPr>
-        <p:txBody>
-          <a:bodyPr wrap="square" lIns="0" rIns="0">
-            <a:spAutoFit/>
-          </a:bodyPr>
-          <a:lstStyle/>
-          <a:p>
-            <a:pPr algn="l">
-              <a:defRPr sz="1400" b="1">
-                <a:solidFill>
-                  <a:srgbClr val="E91E8C"/>
-                </a:solidFill>
-                <a:latin typeface="Calibri"/>
-              </a:defRPr>
-            </a:pPr>
-            <a:r>
-              <a:t>🛠  Mentimeter</a:t>
-            </a:r>
-          </a:p>
-        </p:txBody>
-      </p:sp>
-      <p:sp>
-        <p:nvSpPr>
-          <p:cNvPr id="6" name="TextBox 5"/>
-          <p:cNvSpPr txBox="1"/>
-          <p:nvPr/>
-        </p:nvSpPr>
-        <p:spPr>
-          <a:xfrm>
-            <a:off x="731520" y="2560320"/>
             <a:ext cx="10515600" cy="2011680"/>
           </a:xfrm>
           <a:prstGeom prst="rect">
@@ -5662,7 +5736,16 @@
               </a:defRPr>
             </a:pPr>
             <a:r>
-              <a:t>Eight platform behaviours appear on screen one at a time. For each, vote: is this CORPORATE CONTROL (the platform shaping the young person's options) or USER AGENCY (the young person shaping their own experience within the platform)? Some are both — vote the stronger side. The blurry votes are the real discussion.</a:t>
+              <a:rPr dirty="0"/>
+              <a:t>Eight platform </a:t>
+            </a:r>
+            <a:r>
+              <a:rPr dirty="0" err="1"/>
+              <a:t>behaviours</a:t>
+            </a:r>
+            <a:r>
+              <a:rPr dirty="0"/>
+              <a:t> appear on screen one at a time. For each, vote: is this CORPORATE CONTROL (the platform shaping the young person's options) or USER AGENCY (the young person shaping their own experience within the platform)? Some are both — vote the stronger side. The blurry votes are the real discussion.</a:t>
             </a:r>
           </a:p>
         </p:txBody>
@@ -5675,7 +5758,7 @@
         </p:nvSpPr>
         <p:spPr>
           <a:xfrm>
-            <a:off x="731520" y="4663440"/>
+            <a:off x="731520" y="3520440"/>
             <a:ext cx="10515600" cy="320040"/>
           </a:xfrm>
           <a:prstGeom prst="rect">
@@ -5711,7 +5794,7 @@
         </p:nvSpPr>
         <p:spPr>
           <a:xfrm>
-            <a:off x="731520" y="4983480"/>
+            <a:off x="731520" y="3840480"/>
             <a:ext cx="10515600" cy="2103120"/>
           </a:xfrm>
           <a:prstGeom prst="rect">
@@ -5737,6 +5820,7 @@
               </a:defRPr>
             </a:pPr>
             <a:r>
+              <a:rPr dirty="0"/>
               <a:t>•  The algorithm deciding which 20 videos to show next on TikTok</a:t>
             </a:r>
           </a:p>
@@ -5753,6 +5837,7 @@
               </a:defRPr>
             </a:pPr>
             <a:r>
+              <a:rPr dirty="0"/>
               <a:t>•  A young person creating a second 'finsta' account for close friends</a:t>
             </a:r>
           </a:p>
@@ -5769,6 +5854,7 @@
               </a:defRPr>
             </a:pPr>
             <a:r>
+              <a:rPr dirty="0"/>
               <a:t>•  Default privacy settings being 'public' unless you change them</a:t>
             </a:r>
           </a:p>
@@ -5785,6 +5871,7 @@
               </a:defRPr>
             </a:pPr>
             <a:r>
+              <a:rPr dirty="0"/>
               <a:t>•  A young person blocking their parents across every app</a:t>
             </a:r>
           </a:p>
@@ -5801,7 +5888,16 @@
               </a:defRPr>
             </a:pPr>
             <a:r>
-              <a:t>•  Platform removing a hashtag that was being used to organise protest</a:t>
+              <a:rPr dirty="0"/>
+              <a:t>•  Platform removing a hashtag that was being used to </a:t>
+            </a:r>
+            <a:r>
+              <a:rPr dirty="0" err="1"/>
+              <a:t>organise</a:t>
+            </a:r>
+            <a:r>
+              <a:rPr dirty="0"/>
+              <a:t> protest</a:t>
             </a:r>
           </a:p>
           <a:p>
@@ -5817,6 +5913,7 @@
               </a:defRPr>
             </a:pPr>
             <a:r>
+              <a:rPr dirty="0"/>
               <a:t>•  A young person switching to WhatsApp because Instagram feels performative</a:t>
             </a:r>
           </a:p>
@@ -5833,6 +5930,7 @@
               </a:defRPr>
             </a:pPr>
             <a:r>
+              <a:rPr dirty="0"/>
               <a:t>•  The Terms of Service you clicked 'accept' on without reading</a:t>
             </a:r>
           </a:p>
@@ -5849,6 +5947,7 @@
               </a:defRPr>
             </a:pPr>
             <a:r>
+              <a:rPr dirty="0"/>
               <a:t>•  A young person deleting an app for a week to see how they feel</a:t>
             </a:r>
           </a:p>
@@ -5923,7 +6022,7 @@
 </file>
 
 <file path=ppt/slides/slide18.xml><?xml version="1.0" encoding="utf-8"?>
-<p:sld xmlns:a="http://schemas.openxmlformats.org/drawingml/2006/main" xmlns:p="http://schemas.openxmlformats.org/presentationml/2006/main" xmlns:r="http://schemas.openxmlformats.org/officeDocument/2006/relationships">
+<p:sld xmlns:a="http://schemas.openxmlformats.org/drawingml/2006/main" xmlns:r="http://schemas.openxmlformats.org/officeDocument/2006/relationships" xmlns:p="http://schemas.openxmlformats.org/presentationml/2006/main">
   <p:cSld>
     <p:bg>
       <p:bgPr>
@@ -5939,7 +6038,14 @@
         <p:cNvGrpSpPr/>
         <p:nvPr/>
       </p:nvGrpSpPr>
-      <p:grpSpPr/>
+      <p:grpSpPr>
+        <a:xfrm>
+          <a:off x="0" y="0"/>
+          <a:ext cx="0" cy="0"/>
+          <a:chOff x="0" y="0"/>
+          <a:chExt cx="0" cy="0"/>
+        </a:xfrm>
+      </p:grpSpPr>
       <p:sp>
         <p:nvSpPr>
           <p:cNvPr id="2" name="Rectangle 1"/>
@@ -5980,6 +6086,7 @@
           <a:lstStyle/>
           <a:p>
             <a:pPr algn="ctr"/>
+            <a:endParaRPr/>
           </a:p>
         </p:txBody>
       </p:sp>
@@ -6160,7 +6267,7 @@
 </file>
 
 <file path=ppt/slides/slide19.xml><?xml version="1.0" encoding="utf-8"?>
-<p:sld xmlns:a="http://schemas.openxmlformats.org/drawingml/2006/main" xmlns:p="http://schemas.openxmlformats.org/presentationml/2006/main" xmlns:r="http://schemas.openxmlformats.org/officeDocument/2006/relationships">
+<p:sld xmlns:a="http://schemas.openxmlformats.org/drawingml/2006/main" xmlns:r="http://schemas.openxmlformats.org/officeDocument/2006/relationships" xmlns:p="http://schemas.openxmlformats.org/presentationml/2006/main">
   <p:cSld>
     <p:bg>
       <p:bgPr>
@@ -6176,7 +6283,14 @@
         <p:cNvGrpSpPr/>
         <p:nvPr/>
       </p:nvGrpSpPr>
-      <p:grpSpPr/>
+      <p:grpSpPr>
+        <a:xfrm>
+          <a:off x="0" y="0"/>
+          <a:ext cx="0" cy="0"/>
+          <a:chOff x="0" y="0"/>
+          <a:chExt cx="0" cy="0"/>
+        </a:xfrm>
+      </p:grpSpPr>
       <p:sp>
         <p:nvSpPr>
           <p:cNvPr id="2" name="Rectangle 1"/>
@@ -6217,6 +6331,7 @@
           <a:lstStyle/>
           <a:p>
             <a:pPr algn="ctr"/>
+            <a:endParaRPr/>
           </a:p>
         </p:txBody>
       </p:sp>
@@ -6433,7 +6548,7 @@
 </file>
 
 <file path=ppt/slides/slide2.xml><?xml version="1.0" encoding="utf-8"?>
-<p:sld xmlns:a="http://schemas.openxmlformats.org/drawingml/2006/main" xmlns:p="http://schemas.openxmlformats.org/presentationml/2006/main" xmlns:r="http://schemas.openxmlformats.org/officeDocument/2006/relationships">
+<p:sld xmlns:a="http://schemas.openxmlformats.org/drawingml/2006/main" xmlns:r="http://schemas.openxmlformats.org/officeDocument/2006/relationships" xmlns:p="http://schemas.openxmlformats.org/presentationml/2006/main">
   <p:cSld>
     <p:bg>
       <p:bgPr>
@@ -6449,7 +6564,14 @@
         <p:cNvGrpSpPr/>
         <p:nvPr/>
       </p:nvGrpSpPr>
-      <p:grpSpPr/>
+      <p:grpSpPr>
+        <a:xfrm>
+          <a:off x="0" y="0"/>
+          <a:ext cx="0" cy="0"/>
+          <a:chOff x="0" y="0"/>
+          <a:chExt cx="0" cy="0"/>
+        </a:xfrm>
+      </p:grpSpPr>
       <p:sp>
         <p:nvSpPr>
           <p:cNvPr id="2" name="Rectangle 1"/>
@@ -6490,6 +6612,7 @@
           <a:lstStyle/>
           <a:p>
             <a:pPr algn="ctr"/>
+            <a:endParaRPr/>
           </a:p>
         </p:txBody>
       </p:sp>
@@ -6533,6 +6656,7 @@
           <a:lstStyle/>
           <a:p>
             <a:pPr algn="ctr"/>
+            <a:endParaRPr/>
           </a:p>
         </p:txBody>
       </p:sp>
@@ -6576,6 +6700,7 @@
           <a:lstStyle/>
           <a:p>
             <a:pPr algn="ctr"/>
+            <a:endParaRPr/>
           </a:p>
         </p:txBody>
       </p:sp>
@@ -6891,7 +7016,7 @@
 </file>
 
 <file path=ppt/slides/slide20.xml><?xml version="1.0" encoding="utf-8"?>
-<p:sld xmlns:a="http://schemas.openxmlformats.org/drawingml/2006/main" xmlns:p="http://schemas.openxmlformats.org/presentationml/2006/main" xmlns:r="http://schemas.openxmlformats.org/officeDocument/2006/relationships">
+<p:sld xmlns:a="http://schemas.openxmlformats.org/drawingml/2006/main" xmlns:r="http://schemas.openxmlformats.org/officeDocument/2006/relationships" xmlns:p="http://schemas.openxmlformats.org/presentationml/2006/main">
   <p:cSld>
     <p:bg>
       <p:bgPr>
@@ -6907,7 +7032,14 @@
         <p:cNvGrpSpPr/>
         <p:nvPr/>
       </p:nvGrpSpPr>
-      <p:grpSpPr/>
+      <p:grpSpPr>
+        <a:xfrm>
+          <a:off x="0" y="0"/>
+          <a:ext cx="0" cy="0"/>
+          <a:chOff x="0" y="0"/>
+          <a:chExt cx="0" cy="0"/>
+        </a:xfrm>
+      </p:grpSpPr>
       <p:sp>
         <p:nvSpPr>
           <p:cNvPr id="2" name="Rectangle 1"/>
@@ -6948,6 +7080,7 @@
           <a:lstStyle/>
           <a:p>
             <a:pPr algn="ctr"/>
+            <a:endParaRPr/>
           </a:p>
         </p:txBody>
       </p:sp>
@@ -7128,7 +7261,7 @@
 </file>
 
 <file path=ppt/slides/slide21.xml><?xml version="1.0" encoding="utf-8"?>
-<p:sld xmlns:a="http://schemas.openxmlformats.org/drawingml/2006/main" xmlns:p="http://schemas.openxmlformats.org/presentationml/2006/main" xmlns:r="http://schemas.openxmlformats.org/officeDocument/2006/relationships">
+<p:sld xmlns:a="http://schemas.openxmlformats.org/drawingml/2006/main" xmlns:r="http://schemas.openxmlformats.org/officeDocument/2006/relationships" xmlns:p="http://schemas.openxmlformats.org/presentationml/2006/main">
   <p:cSld>
     <p:bg>
       <p:bgPr>
@@ -7144,7 +7277,14 @@
         <p:cNvGrpSpPr/>
         <p:nvPr/>
       </p:nvGrpSpPr>
-      <p:grpSpPr/>
+      <p:grpSpPr>
+        <a:xfrm>
+          <a:off x="0" y="0"/>
+          <a:ext cx="0" cy="0"/>
+          <a:chOff x="0" y="0"/>
+          <a:chExt cx="0" cy="0"/>
+        </a:xfrm>
+      </p:grpSpPr>
       <p:sp>
         <p:nvSpPr>
           <p:cNvPr id="2" name="Rectangle 1"/>
@@ -7185,6 +7325,7 @@
           <a:lstStyle/>
           <a:p>
             <a:pPr algn="ctr"/>
+            <a:endParaRPr/>
           </a:p>
         </p:txBody>
       </p:sp>
@@ -7480,7 +7621,7 @@
 </file>
 
 <file path=ppt/slides/slide22.xml><?xml version="1.0" encoding="utf-8"?>
-<p:sld xmlns:a="http://schemas.openxmlformats.org/drawingml/2006/main" xmlns:p="http://schemas.openxmlformats.org/presentationml/2006/main" xmlns:r="http://schemas.openxmlformats.org/officeDocument/2006/relationships">
+<p:sld xmlns:a="http://schemas.openxmlformats.org/drawingml/2006/main" xmlns:r="http://schemas.openxmlformats.org/officeDocument/2006/relationships" xmlns:p="http://schemas.openxmlformats.org/presentationml/2006/main">
   <p:cSld>
     <p:bg>
       <p:bgPr>
@@ -7496,7 +7637,14 @@
         <p:cNvGrpSpPr/>
         <p:nvPr/>
       </p:nvGrpSpPr>
-      <p:grpSpPr/>
+      <p:grpSpPr>
+        <a:xfrm>
+          <a:off x="0" y="0"/>
+          <a:ext cx="0" cy="0"/>
+          <a:chOff x="0" y="0"/>
+          <a:chExt cx="0" cy="0"/>
+        </a:xfrm>
+      </p:grpSpPr>
       <p:sp>
         <p:nvSpPr>
           <p:cNvPr id="2" name="Rectangle 1"/>
@@ -7537,6 +7685,7 @@
           <a:lstStyle/>
           <a:p>
             <a:pPr algn="ctr"/>
+            <a:endParaRPr/>
           </a:p>
         </p:txBody>
       </p:sp>
@@ -7753,7 +7902,7 @@
 </file>
 
 <file path=ppt/slides/slide23.xml><?xml version="1.0" encoding="utf-8"?>
-<p:sld xmlns:a="http://schemas.openxmlformats.org/drawingml/2006/main" xmlns:p="http://schemas.openxmlformats.org/presentationml/2006/main" xmlns:r="http://schemas.openxmlformats.org/officeDocument/2006/relationships">
+<p:sld xmlns:a="http://schemas.openxmlformats.org/drawingml/2006/main" xmlns:r="http://schemas.openxmlformats.org/officeDocument/2006/relationships" xmlns:p="http://schemas.openxmlformats.org/presentationml/2006/main">
   <p:cSld>
     <p:bg>
       <p:bgPr>
@@ -7769,7 +7918,14 @@
         <p:cNvGrpSpPr/>
         <p:nvPr/>
       </p:nvGrpSpPr>
-      <p:grpSpPr/>
+      <p:grpSpPr>
+        <a:xfrm>
+          <a:off x="0" y="0"/>
+          <a:ext cx="0" cy="0"/>
+          <a:chOff x="0" y="0"/>
+          <a:chExt cx="0" cy="0"/>
+        </a:xfrm>
+      </p:grpSpPr>
       <p:sp>
         <p:nvSpPr>
           <p:cNvPr id="2" name="Rectangle 1"/>
@@ -7810,6 +7966,7 @@
           <a:lstStyle/>
           <a:p>
             <a:pPr algn="ctr"/>
+            <a:endParaRPr/>
           </a:p>
         </p:txBody>
       </p:sp>
@@ -7990,7 +8147,7 @@
 </file>
 
 <file path=ppt/slides/slide24.xml><?xml version="1.0" encoding="utf-8"?>
-<p:sld xmlns:a="http://schemas.openxmlformats.org/drawingml/2006/main" xmlns:p="http://schemas.openxmlformats.org/presentationml/2006/main" xmlns:r="http://schemas.openxmlformats.org/officeDocument/2006/relationships">
+<p:sld xmlns:a="http://schemas.openxmlformats.org/drawingml/2006/main" xmlns:r="http://schemas.openxmlformats.org/officeDocument/2006/relationships" xmlns:p="http://schemas.openxmlformats.org/presentationml/2006/main">
   <p:cSld>
     <p:bg>
       <p:bgPr>
@@ -8006,7 +8163,14 @@
         <p:cNvGrpSpPr/>
         <p:nvPr/>
       </p:nvGrpSpPr>
-      <p:grpSpPr/>
+      <p:grpSpPr>
+        <a:xfrm>
+          <a:off x="0" y="0"/>
+          <a:ext cx="0" cy="0"/>
+          <a:chOff x="0" y="0"/>
+          <a:chExt cx="0" cy="0"/>
+        </a:xfrm>
+      </p:grpSpPr>
       <p:sp>
         <p:nvSpPr>
           <p:cNvPr id="2" name="Rectangle 1"/>
@@ -8047,6 +8211,7 @@
           <a:lstStyle/>
           <a:p>
             <a:pPr algn="ctr"/>
+            <a:endParaRPr/>
           </a:p>
         </p:txBody>
       </p:sp>
@@ -8382,7 +8547,7 @@
 </file>
 
 <file path=ppt/slides/slide25.xml><?xml version="1.0" encoding="utf-8"?>
-<p:sld xmlns:a="http://schemas.openxmlformats.org/drawingml/2006/main" xmlns:p="http://schemas.openxmlformats.org/presentationml/2006/main" xmlns:r="http://schemas.openxmlformats.org/officeDocument/2006/relationships">
+<p:sld xmlns:a="http://schemas.openxmlformats.org/drawingml/2006/main" xmlns:r="http://schemas.openxmlformats.org/officeDocument/2006/relationships" xmlns:p="http://schemas.openxmlformats.org/presentationml/2006/main">
   <p:cSld>
     <p:bg>
       <p:bgPr>
@@ -8398,7 +8563,14 @@
         <p:cNvGrpSpPr/>
         <p:nvPr/>
       </p:nvGrpSpPr>
-      <p:grpSpPr/>
+      <p:grpSpPr>
+        <a:xfrm>
+          <a:off x="0" y="0"/>
+          <a:ext cx="0" cy="0"/>
+          <a:chOff x="0" y="0"/>
+          <a:chExt cx="0" cy="0"/>
+        </a:xfrm>
+      </p:grpSpPr>
       <p:sp>
         <p:nvSpPr>
           <p:cNvPr id="2" name="Rectangle 1"/>
@@ -8439,6 +8611,7 @@
           <a:lstStyle/>
           <a:p>
             <a:pPr algn="ctr"/>
+            <a:endParaRPr/>
           </a:p>
         </p:txBody>
       </p:sp>
@@ -8655,7 +8828,7 @@
 </file>
 
 <file path=ppt/slides/slide26.xml><?xml version="1.0" encoding="utf-8"?>
-<p:sld xmlns:a="http://schemas.openxmlformats.org/drawingml/2006/main" xmlns:p="http://schemas.openxmlformats.org/presentationml/2006/main" xmlns:r="http://schemas.openxmlformats.org/officeDocument/2006/relationships">
+<p:sld xmlns:a="http://schemas.openxmlformats.org/drawingml/2006/main" xmlns:r="http://schemas.openxmlformats.org/officeDocument/2006/relationships" xmlns:p="http://schemas.openxmlformats.org/presentationml/2006/main">
   <p:cSld>
     <p:bg>
       <p:bgPr>
@@ -8671,7 +8844,14 @@
         <p:cNvGrpSpPr/>
         <p:nvPr/>
       </p:nvGrpSpPr>
-      <p:grpSpPr/>
+      <p:grpSpPr>
+        <a:xfrm>
+          <a:off x="0" y="0"/>
+          <a:ext cx="0" cy="0"/>
+          <a:chOff x="0" y="0"/>
+          <a:chExt cx="0" cy="0"/>
+        </a:xfrm>
+      </p:grpSpPr>
       <p:sp>
         <p:nvSpPr>
           <p:cNvPr id="2" name="Rectangle 1"/>
@@ -8712,6 +8892,7 @@
           <a:lstStyle/>
           <a:p>
             <a:pPr algn="ctr"/>
+            <a:endParaRPr/>
           </a:p>
         </p:txBody>
       </p:sp>
@@ -8892,7 +9073,7 @@
 </file>
 
 <file path=ppt/slides/slide27.xml><?xml version="1.0" encoding="utf-8"?>
-<p:sld xmlns:a="http://schemas.openxmlformats.org/drawingml/2006/main" xmlns:p="http://schemas.openxmlformats.org/presentationml/2006/main" xmlns:r="http://schemas.openxmlformats.org/officeDocument/2006/relationships">
+<p:sld xmlns:a="http://schemas.openxmlformats.org/drawingml/2006/main" xmlns:r="http://schemas.openxmlformats.org/officeDocument/2006/relationships" xmlns:p="http://schemas.openxmlformats.org/presentationml/2006/main">
   <p:cSld>
     <p:bg>
       <p:bgPr>
@@ -8908,7 +9089,14 @@
         <p:cNvGrpSpPr/>
         <p:nvPr/>
       </p:nvGrpSpPr>
-      <p:grpSpPr/>
+      <p:grpSpPr>
+        <a:xfrm>
+          <a:off x="0" y="0"/>
+          <a:ext cx="0" cy="0"/>
+          <a:chOff x="0" y="0"/>
+          <a:chExt cx="0" cy="0"/>
+        </a:xfrm>
+      </p:grpSpPr>
       <p:sp>
         <p:nvSpPr>
           <p:cNvPr id="2" name="Rectangle 1"/>
@@ -8949,6 +9137,7 @@
           <a:lstStyle/>
           <a:p>
             <a:pPr algn="ctr"/>
+            <a:endParaRPr/>
           </a:p>
         </p:txBody>
       </p:sp>
@@ -9141,7 +9330,7 @@
 </file>
 
 <file path=ppt/slides/slide28.xml><?xml version="1.0" encoding="utf-8"?>
-<p:sld xmlns:a="http://schemas.openxmlformats.org/drawingml/2006/main" xmlns:p="http://schemas.openxmlformats.org/presentationml/2006/main" xmlns:r="http://schemas.openxmlformats.org/officeDocument/2006/relationships">
+<p:sld xmlns:a="http://schemas.openxmlformats.org/drawingml/2006/main" xmlns:r="http://schemas.openxmlformats.org/officeDocument/2006/relationships" xmlns:p="http://schemas.openxmlformats.org/presentationml/2006/main">
   <p:cSld>
     <p:bg>
       <p:bgPr>
@@ -9157,7 +9346,14 @@
         <p:cNvGrpSpPr/>
         <p:nvPr/>
       </p:nvGrpSpPr>
-      <p:grpSpPr/>
+      <p:grpSpPr>
+        <a:xfrm>
+          <a:off x="0" y="0"/>
+          <a:ext cx="0" cy="0"/>
+          <a:chOff x="0" y="0"/>
+          <a:chExt cx="0" cy="0"/>
+        </a:xfrm>
+      </p:grpSpPr>
       <p:sp>
         <p:nvSpPr>
           <p:cNvPr id="2" name="Rectangle 1"/>
@@ -9198,6 +9394,7 @@
           <a:lstStyle/>
           <a:p>
             <a:pPr algn="ctr"/>
+            <a:endParaRPr/>
           </a:p>
         </p:txBody>
       </p:sp>
@@ -9414,7 +9611,7 @@
 </file>
 
 <file path=ppt/slides/slide29.xml><?xml version="1.0" encoding="utf-8"?>
-<p:sld xmlns:a="http://schemas.openxmlformats.org/drawingml/2006/main" xmlns:p="http://schemas.openxmlformats.org/presentationml/2006/main" xmlns:r="http://schemas.openxmlformats.org/officeDocument/2006/relationships">
+<p:sld xmlns:a="http://schemas.openxmlformats.org/drawingml/2006/main" xmlns:r="http://schemas.openxmlformats.org/officeDocument/2006/relationships" xmlns:p="http://schemas.openxmlformats.org/presentationml/2006/main">
   <p:cSld>
     <p:bg>
       <p:bgPr>
@@ -9430,7 +9627,14 @@
         <p:cNvGrpSpPr/>
         <p:nvPr/>
       </p:nvGrpSpPr>
-      <p:grpSpPr/>
+      <p:grpSpPr>
+        <a:xfrm>
+          <a:off x="0" y="0"/>
+          <a:ext cx="0" cy="0"/>
+          <a:chOff x="0" y="0"/>
+          <a:chExt cx="0" cy="0"/>
+        </a:xfrm>
+      </p:grpSpPr>
       <p:sp>
         <p:nvSpPr>
           <p:cNvPr id="2" name="Rectangle 1"/>
@@ -9471,6 +9675,7 @@
           <a:lstStyle/>
           <a:p>
             <a:pPr algn="ctr"/>
+            <a:endParaRPr/>
           </a:p>
         </p:txBody>
       </p:sp>
@@ -9651,7 +9856,7 @@
 </file>
 
 <file path=ppt/slides/slide3.xml><?xml version="1.0" encoding="utf-8"?>
-<p:sld xmlns:a="http://schemas.openxmlformats.org/drawingml/2006/main" xmlns:p="http://schemas.openxmlformats.org/presentationml/2006/main" xmlns:r="http://schemas.openxmlformats.org/officeDocument/2006/relationships">
+<p:sld xmlns:a="http://schemas.openxmlformats.org/drawingml/2006/main" xmlns:r="http://schemas.openxmlformats.org/officeDocument/2006/relationships" xmlns:p="http://schemas.openxmlformats.org/presentationml/2006/main">
   <p:cSld>
     <p:bg>
       <p:bgPr>
@@ -9667,7 +9872,14 @@
         <p:cNvGrpSpPr/>
         <p:nvPr/>
       </p:nvGrpSpPr>
-      <p:grpSpPr/>
+      <p:grpSpPr>
+        <a:xfrm>
+          <a:off x="0" y="0"/>
+          <a:ext cx="0" cy="0"/>
+          <a:chOff x="0" y="0"/>
+          <a:chExt cx="0" cy="0"/>
+        </a:xfrm>
+      </p:grpSpPr>
       <p:sp>
         <p:nvSpPr>
           <p:cNvPr id="2" name="Rectangle 1"/>
@@ -9708,6 +9920,7 @@
           <a:lstStyle/>
           <a:p>
             <a:pPr algn="ctr"/>
+            <a:endParaRPr/>
           </a:p>
         </p:txBody>
       </p:sp>
@@ -9900,7 +10113,7 @@
 </file>
 
 <file path=ppt/slides/slide30.xml><?xml version="1.0" encoding="utf-8"?>
-<p:sld xmlns:a="http://schemas.openxmlformats.org/drawingml/2006/main" xmlns:p="http://schemas.openxmlformats.org/presentationml/2006/main" xmlns:r="http://schemas.openxmlformats.org/officeDocument/2006/relationships">
+<p:sld xmlns:a="http://schemas.openxmlformats.org/drawingml/2006/main" xmlns:r="http://schemas.openxmlformats.org/officeDocument/2006/relationships" xmlns:p="http://schemas.openxmlformats.org/presentationml/2006/main">
   <p:cSld>
     <p:bg>
       <p:bgPr>
@@ -9916,7 +10129,14 @@
         <p:cNvGrpSpPr/>
         <p:nvPr/>
       </p:nvGrpSpPr>
-      <p:grpSpPr/>
+      <p:grpSpPr>
+        <a:xfrm>
+          <a:off x="0" y="0"/>
+          <a:ext cx="0" cy="0"/>
+          <a:chOff x="0" y="0"/>
+          <a:chExt cx="0" cy="0"/>
+        </a:xfrm>
+      </p:grpSpPr>
       <p:sp>
         <p:nvSpPr>
           <p:cNvPr id="2" name="Rectangle 1"/>
@@ -9957,6 +10177,7 @@
           <a:lstStyle/>
           <a:p>
             <a:pPr algn="ctr"/>
+            <a:endParaRPr/>
           </a:p>
         </p:txBody>
       </p:sp>
@@ -10173,7 +10394,7 @@
 </file>
 
 <file path=ppt/slides/slide31.xml><?xml version="1.0" encoding="utf-8"?>
-<p:sld xmlns:a="http://schemas.openxmlformats.org/drawingml/2006/main" xmlns:p="http://schemas.openxmlformats.org/presentationml/2006/main" xmlns:r="http://schemas.openxmlformats.org/officeDocument/2006/relationships">
+<p:sld xmlns:a="http://schemas.openxmlformats.org/drawingml/2006/main" xmlns:r="http://schemas.openxmlformats.org/officeDocument/2006/relationships" xmlns:p="http://schemas.openxmlformats.org/presentationml/2006/main">
   <p:cSld>
     <p:bg>
       <p:bgPr>
@@ -10189,7 +10410,14 @@
         <p:cNvGrpSpPr/>
         <p:nvPr/>
       </p:nvGrpSpPr>
-      <p:grpSpPr/>
+      <p:grpSpPr>
+        <a:xfrm>
+          <a:off x="0" y="0"/>
+          <a:ext cx="0" cy="0"/>
+          <a:chOff x="0" y="0"/>
+          <a:chExt cx="0" cy="0"/>
+        </a:xfrm>
+      </p:grpSpPr>
       <p:sp>
         <p:nvSpPr>
           <p:cNvPr id="2" name="Rectangle 1"/>
@@ -10230,6 +10458,7 @@
           <a:lstStyle/>
           <a:p>
             <a:pPr algn="ctr"/>
+            <a:endParaRPr/>
           </a:p>
         </p:txBody>
       </p:sp>
@@ -10410,7 +10639,7 @@
 </file>
 
 <file path=ppt/slides/slide32.xml><?xml version="1.0" encoding="utf-8"?>
-<p:sld xmlns:a="http://schemas.openxmlformats.org/drawingml/2006/main" xmlns:p="http://schemas.openxmlformats.org/presentationml/2006/main" xmlns:r="http://schemas.openxmlformats.org/officeDocument/2006/relationships">
+<p:sld xmlns:a="http://schemas.openxmlformats.org/drawingml/2006/main" xmlns:r="http://schemas.openxmlformats.org/officeDocument/2006/relationships" xmlns:p="http://schemas.openxmlformats.org/presentationml/2006/main">
   <p:cSld>
     <p:bg>
       <p:bgPr>
@@ -10426,7 +10655,14 @@
         <p:cNvGrpSpPr/>
         <p:nvPr/>
       </p:nvGrpSpPr>
-      <p:grpSpPr/>
+      <p:grpSpPr>
+        <a:xfrm>
+          <a:off x="0" y="0"/>
+          <a:ext cx="0" cy="0"/>
+          <a:chOff x="0" y="0"/>
+          <a:chExt cx="0" cy="0"/>
+        </a:xfrm>
+      </p:grpSpPr>
       <p:sp>
         <p:nvSpPr>
           <p:cNvPr id="2" name="Rectangle 1"/>
@@ -10467,6 +10703,7 @@
           <a:lstStyle/>
           <a:p>
             <a:pPr algn="ctr"/>
+            <a:endParaRPr/>
           </a:p>
         </p:txBody>
       </p:sp>
@@ -10510,6 +10747,7 @@
           <a:lstStyle/>
           <a:p>
             <a:pPr algn="ctr"/>
+            <a:endParaRPr/>
           </a:p>
         </p:txBody>
       </p:sp>
@@ -10553,6 +10791,7 @@
           <a:lstStyle/>
           <a:p>
             <a:pPr algn="ctr"/>
+            <a:endParaRPr/>
           </a:p>
         </p:txBody>
       </p:sp>
@@ -10733,7 +10972,7 @@
 </file>
 
 <file path=ppt/slides/slide4.xml><?xml version="1.0" encoding="utf-8"?>
-<p:sld xmlns:a="http://schemas.openxmlformats.org/drawingml/2006/main" xmlns:p="http://schemas.openxmlformats.org/presentationml/2006/main" xmlns:r="http://schemas.openxmlformats.org/officeDocument/2006/relationships">
+<p:sld xmlns:a="http://schemas.openxmlformats.org/drawingml/2006/main" xmlns:r="http://schemas.openxmlformats.org/officeDocument/2006/relationships" xmlns:p="http://schemas.openxmlformats.org/presentationml/2006/main">
   <p:cSld>
     <p:bg>
       <p:bgPr>
@@ -10749,7 +10988,14 @@
         <p:cNvGrpSpPr/>
         <p:nvPr/>
       </p:nvGrpSpPr>
-      <p:grpSpPr/>
+      <p:grpSpPr>
+        <a:xfrm>
+          <a:off x="0" y="0"/>
+          <a:ext cx="0" cy="0"/>
+          <a:chOff x="0" y="0"/>
+          <a:chExt cx="0" cy="0"/>
+        </a:xfrm>
+      </p:grpSpPr>
       <p:sp>
         <p:nvSpPr>
           <p:cNvPr id="2" name="Rectangle 1"/>
@@ -10790,6 +11036,7 @@
           <a:lstStyle/>
           <a:p>
             <a:pPr algn="ctr"/>
+            <a:endParaRPr/>
           </a:p>
         </p:txBody>
       </p:sp>
@@ -11006,7 +11253,7 @@
 </file>
 
 <file path=ppt/slides/slide5.xml><?xml version="1.0" encoding="utf-8"?>
-<p:sld xmlns:a="http://schemas.openxmlformats.org/drawingml/2006/main" xmlns:p="http://schemas.openxmlformats.org/presentationml/2006/main" xmlns:r="http://schemas.openxmlformats.org/officeDocument/2006/relationships">
+<p:sld xmlns:a="http://schemas.openxmlformats.org/drawingml/2006/main" xmlns:r="http://schemas.openxmlformats.org/officeDocument/2006/relationships" xmlns:p="http://schemas.openxmlformats.org/presentationml/2006/main">
   <p:cSld>
     <p:bg>
       <p:bgPr>
@@ -11022,7 +11269,14 @@
         <p:cNvGrpSpPr/>
         <p:nvPr/>
       </p:nvGrpSpPr>
-      <p:grpSpPr/>
+      <p:grpSpPr>
+        <a:xfrm>
+          <a:off x="0" y="0"/>
+          <a:ext cx="0" cy="0"/>
+          <a:chOff x="0" y="0"/>
+          <a:chExt cx="0" cy="0"/>
+        </a:xfrm>
+      </p:grpSpPr>
       <p:sp>
         <p:nvSpPr>
           <p:cNvPr id="2" name="Rectangle 1"/>
@@ -11063,6 +11317,7 @@
           <a:lstStyle/>
           <a:p>
             <a:pPr algn="ctr"/>
+            <a:endParaRPr/>
           </a:p>
         </p:txBody>
       </p:sp>
@@ -11279,7 +11534,7 @@
 </file>
 
 <file path=ppt/slides/slide6.xml><?xml version="1.0" encoding="utf-8"?>
-<p:sld xmlns:a="http://schemas.openxmlformats.org/drawingml/2006/main" xmlns:p="http://schemas.openxmlformats.org/presentationml/2006/main" xmlns:r="http://schemas.openxmlformats.org/officeDocument/2006/relationships">
+<p:sld xmlns:a="http://schemas.openxmlformats.org/drawingml/2006/main" xmlns:r="http://schemas.openxmlformats.org/officeDocument/2006/relationships" xmlns:p="http://schemas.openxmlformats.org/presentationml/2006/main">
   <p:cSld>
     <p:bg>
       <p:bgPr>
@@ -11295,7 +11550,14 @@
         <p:cNvGrpSpPr/>
         <p:nvPr/>
       </p:nvGrpSpPr>
-      <p:grpSpPr/>
+      <p:grpSpPr>
+        <a:xfrm>
+          <a:off x="0" y="0"/>
+          <a:ext cx="0" cy="0"/>
+          <a:chOff x="0" y="0"/>
+          <a:chExt cx="0" cy="0"/>
+        </a:xfrm>
+      </p:grpSpPr>
       <p:sp>
         <p:nvSpPr>
           <p:cNvPr id="2" name="Rectangle 1"/>
@@ -11336,6 +11598,7 @@
           <a:lstStyle/>
           <a:p>
             <a:pPr algn="ctr"/>
+            <a:endParaRPr/>
           </a:p>
         </p:txBody>
       </p:sp>
@@ -11552,7 +11815,7 @@
 </file>
 
 <file path=ppt/slides/slide7.xml><?xml version="1.0" encoding="utf-8"?>
-<p:sld xmlns:a="http://schemas.openxmlformats.org/drawingml/2006/main" xmlns:p="http://schemas.openxmlformats.org/presentationml/2006/main" xmlns:r="http://schemas.openxmlformats.org/officeDocument/2006/relationships">
+<p:sld xmlns:a="http://schemas.openxmlformats.org/drawingml/2006/main" xmlns:r="http://schemas.openxmlformats.org/officeDocument/2006/relationships" xmlns:p="http://schemas.openxmlformats.org/presentationml/2006/main">
   <p:cSld>
     <p:bg>
       <p:bgPr>
@@ -11568,7 +11831,14 @@
         <p:cNvGrpSpPr/>
         <p:nvPr/>
       </p:nvGrpSpPr>
-      <p:grpSpPr/>
+      <p:grpSpPr>
+        <a:xfrm>
+          <a:off x="0" y="0"/>
+          <a:ext cx="0" cy="0"/>
+          <a:chOff x="0" y="0"/>
+          <a:chExt cx="0" cy="0"/>
+        </a:xfrm>
+      </p:grpSpPr>
       <p:sp>
         <p:nvSpPr>
           <p:cNvPr id="2" name="Rectangle 1"/>
@@ -11609,6 +11879,7 @@
           <a:lstStyle/>
           <a:p>
             <a:pPr algn="ctr"/>
+            <a:endParaRPr/>
           </a:p>
         </p:txBody>
       </p:sp>
@@ -11789,7 +12060,7 @@
 </file>
 
 <file path=ppt/slides/slide8.xml><?xml version="1.0" encoding="utf-8"?>
-<p:sld xmlns:a="http://schemas.openxmlformats.org/drawingml/2006/main" xmlns:p="http://schemas.openxmlformats.org/presentationml/2006/main" xmlns:r="http://schemas.openxmlformats.org/officeDocument/2006/relationships">
+<p:sld xmlns:a="http://schemas.openxmlformats.org/drawingml/2006/main" xmlns:r="http://schemas.openxmlformats.org/officeDocument/2006/relationships" xmlns:p="http://schemas.openxmlformats.org/presentationml/2006/main">
   <p:cSld>
     <p:bg>
       <p:bgPr>
@@ -11805,7 +12076,14 @@
         <p:cNvGrpSpPr/>
         <p:nvPr/>
       </p:nvGrpSpPr>
-      <p:grpSpPr/>
+      <p:grpSpPr>
+        <a:xfrm>
+          <a:off x="0" y="0"/>
+          <a:ext cx="0" cy="0"/>
+          <a:chOff x="0" y="0"/>
+          <a:chExt cx="0" cy="0"/>
+        </a:xfrm>
+      </p:grpSpPr>
       <p:sp>
         <p:nvSpPr>
           <p:cNvPr id="2" name="Rectangle 1"/>
@@ -11846,6 +12124,7 @@
           <a:lstStyle/>
           <a:p>
             <a:pPr algn="ctr"/>
+            <a:endParaRPr/>
           </a:p>
         </p:txBody>
       </p:sp>
@@ -12026,7 +12305,7 @@
 </file>
 
 <file path=ppt/slides/slide9.xml><?xml version="1.0" encoding="utf-8"?>
-<p:sld xmlns:a="http://schemas.openxmlformats.org/drawingml/2006/main" xmlns:p="http://schemas.openxmlformats.org/presentationml/2006/main" xmlns:r="http://schemas.openxmlformats.org/officeDocument/2006/relationships">
+<p:sld xmlns:a="http://schemas.openxmlformats.org/drawingml/2006/main" xmlns:r="http://schemas.openxmlformats.org/officeDocument/2006/relationships" xmlns:p="http://schemas.openxmlformats.org/presentationml/2006/main">
   <p:cSld>
     <p:bg>
       <p:bgPr>
@@ -12042,7 +12321,14 @@
         <p:cNvGrpSpPr/>
         <p:nvPr/>
       </p:nvGrpSpPr>
-      <p:grpSpPr/>
+      <p:grpSpPr>
+        <a:xfrm>
+          <a:off x="0" y="0"/>
+          <a:ext cx="0" cy="0"/>
+          <a:chOff x="0" y="0"/>
+          <a:chExt cx="0" cy="0"/>
+        </a:xfrm>
+      </p:grpSpPr>
       <p:sp>
         <p:nvSpPr>
           <p:cNvPr id="2" name="Rectangle 1"/>
@@ -12083,6 +12369,7 @@
           <a:lstStyle/>
           <a:p>
             <a:pPr algn="ctr"/>
+            <a:endParaRPr/>
           </a:p>
         </p:txBody>
       </p:sp>

</xml_diff>